<commit_message>
Add telemetry plots and microflare case study slides to presentation
</commit_message>
<xml_diff>
--- a/AdityaL1_SolarFlare_Presentation.pptx
+++ b/AdityaL1_SolarFlare_Presentation.pptx
@@ -15,6 +15,8 @@
     <p:sldId id="263" r:id="rId14"/>
     <p:sldId id="264" r:id="rId15"/>
     <p:sldId id="265" r:id="rId16"/>
+    <p:sldId id="266" r:id="rId17"/>
+    <p:sldId id="267" r:id="rId18"/>
   </p:sldIdLst>
   <p:sldSz cx="12188952" cy="6858000" type="screen4x3"/>
   <p:notesSz cx="6858000" cy="9144000"/>
@@ -3343,6 +3345,709 @@
               </a:defRPr>
             </a:pPr>
             <a:r>
+              <a:t>Development Roadmap</a:t>
+            </a:r>
+          </a:p>
+        </p:txBody>
+      </p:sp>
+      <p:sp>
+        <p:nvSpPr>
+          <p:cNvPr id="4" name="Rectangle 3"/>
+          <p:cNvSpPr/>
+          <p:nvPr/>
+        </p:nvSpPr>
+        <p:spPr>
+          <a:xfrm>
+            <a:off x="685800" y="1234440"/>
+            <a:ext cx="10817352" cy="54864"/>
+          </a:xfrm>
+          <a:prstGeom prst="rect">
+            <a:avLst/>
+          </a:prstGeom>
+          <a:solidFill>
+            <a:srgbClr val="009664"/>
+          </a:solidFill>
+          <a:ln>
+            <a:noFill/>
+          </a:ln>
+        </p:spPr>
+        <p:style>
+          <a:lnRef idx="1">
+            <a:schemeClr val="accent1"/>
+          </a:lnRef>
+          <a:fillRef idx="3">
+            <a:schemeClr val="accent1"/>
+          </a:fillRef>
+          <a:effectRef idx="2">
+            <a:schemeClr val="accent1"/>
+          </a:effectRef>
+          <a:fontRef idx="minor">
+            <a:schemeClr val="lt1"/>
+          </a:fontRef>
+        </p:style>
+        <p:txBody>
+          <a:bodyPr rtlCol="0" anchor="ctr"/>
+          <a:lstStyle/>
+          <a:p>
+            <a:pPr algn="ctr"/>
+          </a:p>
+        </p:txBody>
+      </p:sp>
+      <p:sp>
+        <p:nvSpPr>
+          <p:cNvPr id="5" name="Rounded Rectangle 4"/>
+          <p:cNvSpPr/>
+          <p:nvPr/>
+        </p:nvSpPr>
+        <p:spPr>
+          <a:xfrm>
+            <a:off x="685800" y="1645920"/>
+            <a:ext cx="3474720" cy="4389120"/>
+          </a:xfrm>
+          <a:prstGeom prst="roundRect">
+            <a:avLst/>
+          </a:prstGeom>
+          <a:solidFill>
+            <a:srgbClr val="FFFFFF"/>
+          </a:solidFill>
+          <a:ln w="19050">
+            <a:solidFill>
+              <a:srgbClr val="009664"/>
+            </a:solidFill>
+          </a:ln>
+        </p:spPr>
+        <p:style>
+          <a:lnRef idx="1">
+            <a:schemeClr val="accent1"/>
+          </a:lnRef>
+          <a:fillRef idx="3">
+            <a:schemeClr val="accent1"/>
+          </a:fillRef>
+          <a:effectRef idx="2">
+            <a:schemeClr val="accent1"/>
+          </a:effectRef>
+          <a:fontRef idx="minor">
+            <a:schemeClr val="lt1"/>
+          </a:fontRef>
+        </p:style>
+        <p:txBody>
+          <a:bodyPr rtlCol="0" anchor="ctr" wrap="square" lIns="182880" rIns="182880" tIns="182880" bIns="182880"/>
+          <a:lstStyle/>
+          <a:p>
+            <a:pPr algn="ctr">
+              <a:spcAft>
+                <a:spcPts val="1200"/>
+              </a:spcAft>
+              <a:defRPr sz="1600" b="1">
+                <a:solidFill>
+                  <a:srgbClr val="009664"/>
+                </a:solidFill>
+                <a:latin typeface="Arial"/>
+              </a:defRPr>
+            </a:pPr>
+            <a:r>
+              <a:t>Phase 1: Proof of Concept (Implemented)</a:t>
+            </a:r>
+          </a:p>
+          <a:p>
+            <a:pPr>
+              <a:spcAft>
+                <a:spcPts val="800"/>
+              </a:spcAft>
+              <a:defRPr sz="1300">
+                <a:solidFill>
+                  <a:srgbClr val="282828"/>
+                </a:solidFill>
+                <a:latin typeface="Arial"/>
+              </a:defRPr>
+            </a:pPr>
+            <a:r>
+              <a:t>• Harmonized raw SoLEXS and HEL1OS FITS telemetry.</a:t>
+            </a:r>
+            <a:br/>
+            <a:r>
+              <a:t>• Built causal rolling nowcaster (93.2% recall vs. GOES).</a:t>
+            </a:r>
+            <a:br/>
+            <a:r>
+              <a:t>• Trained RandomForest forecasters using time-based holdout.</a:t>
+            </a:r>
+            <a:br/>
+            <a:r>
+              <a:t>• Deployed operator dashboard with live alerts &amp; localtunnel.</a:t>
+            </a:r>
+          </a:p>
+        </p:txBody>
+      </p:sp>
+      <p:sp>
+        <p:nvSpPr>
+          <p:cNvPr id="6" name="Rounded Rectangle 5"/>
+          <p:cNvSpPr/>
+          <p:nvPr/>
+        </p:nvSpPr>
+        <p:spPr>
+          <a:xfrm>
+            <a:off x="4343400" y="1645920"/>
+            <a:ext cx="3474720" cy="4389120"/>
+          </a:xfrm>
+          <a:prstGeom prst="roundRect">
+            <a:avLst/>
+          </a:prstGeom>
+          <a:solidFill>
+            <a:srgbClr val="FFFFFF"/>
+          </a:solidFill>
+          <a:ln w="19050">
+            <a:solidFill>
+              <a:srgbClr val="002060"/>
+            </a:solidFill>
+          </a:ln>
+        </p:spPr>
+        <p:style>
+          <a:lnRef idx="1">
+            <a:schemeClr val="accent1"/>
+          </a:lnRef>
+          <a:fillRef idx="3">
+            <a:schemeClr val="accent1"/>
+          </a:fillRef>
+          <a:effectRef idx="2">
+            <a:schemeClr val="accent1"/>
+          </a:effectRef>
+          <a:fontRef idx="minor">
+            <a:schemeClr val="lt1"/>
+          </a:fontRef>
+        </p:style>
+        <p:txBody>
+          <a:bodyPr rtlCol="0" anchor="ctr" wrap="square" lIns="182880" rIns="182880" tIns="182880" bIns="182880"/>
+          <a:lstStyle/>
+          <a:p>
+            <a:pPr algn="ctr">
+              <a:spcAft>
+                <a:spcPts val="1200"/>
+              </a:spcAft>
+              <a:defRPr sz="1600" b="1">
+                <a:solidFill>
+                  <a:srgbClr val="002060"/>
+                </a:solidFill>
+                <a:latin typeface="Arial"/>
+              </a:defRPr>
+            </a:pPr>
+            <a:r>
+              <a:t>Phase 2: Prototype Scaling &amp; Calibration (2-3 Months)</a:t>
+            </a:r>
+          </a:p>
+          <a:p>
+            <a:pPr>
+              <a:spcAft>
+                <a:spcPts val="800"/>
+              </a:spcAft>
+              <a:defRPr sz="1300">
+                <a:solidFill>
+                  <a:srgbClr val="282828"/>
+                </a:solidFill>
+                <a:latin typeface="Arial"/>
+              </a:defRPr>
+            </a:pPr>
+            <a:r>
+              <a:t>• Process multi-month Aditya-L1 archives (100-150+ major flares).</a:t>
+            </a:r>
+            <a:br/>
+            <a:r>
+              <a:t>• Integrate Detector Response Matrices (DRMs) for physical flux unit conversion.</a:t>
+            </a:r>
+            <a:br/>
+            <a:r>
+              <a:t>• Ingest spacecraft attitude telemetry for collimator area corrections.</a:t>
+            </a:r>
+            <a:br/>
+            <a:r>
+              <a:t>• Implement veto-detector background subtraction.</a:t>
+            </a:r>
+          </a:p>
+        </p:txBody>
+      </p:sp>
+      <p:sp>
+        <p:nvSpPr>
+          <p:cNvPr id="7" name="Rounded Rectangle 6"/>
+          <p:cNvSpPr/>
+          <p:nvPr/>
+        </p:nvSpPr>
+        <p:spPr>
+          <a:xfrm>
+            <a:off x="8001000" y="1645920"/>
+            <a:ext cx="3474720" cy="4389120"/>
+          </a:xfrm>
+          <a:prstGeom prst="roundRect">
+            <a:avLst/>
+          </a:prstGeom>
+          <a:solidFill>
+            <a:srgbClr val="FFFFFF"/>
+          </a:solidFill>
+          <a:ln w="19050">
+            <a:solidFill>
+              <a:srgbClr val="002060"/>
+            </a:solidFill>
+          </a:ln>
+        </p:spPr>
+        <p:style>
+          <a:lnRef idx="1">
+            <a:schemeClr val="accent1"/>
+          </a:lnRef>
+          <a:fillRef idx="3">
+            <a:schemeClr val="accent1"/>
+          </a:fillRef>
+          <a:effectRef idx="2">
+            <a:schemeClr val="accent1"/>
+          </a:effectRef>
+          <a:fontRef idx="minor">
+            <a:schemeClr val="lt1"/>
+          </a:fontRef>
+        </p:style>
+        <p:txBody>
+          <a:bodyPr rtlCol="0" anchor="ctr" wrap="square" lIns="182880" rIns="182880" tIns="182880" bIns="182880"/>
+          <a:lstStyle/>
+          <a:p>
+            <a:pPr algn="ctr">
+              <a:spcAft>
+                <a:spcPts val="1200"/>
+              </a:spcAft>
+              <a:defRPr sz="1600" b="1">
+                <a:solidFill>
+                  <a:srgbClr val="002060"/>
+                </a:solidFill>
+                <a:latin typeface="Arial"/>
+              </a:defRPr>
+            </a:pPr>
+            <a:r>
+              <a:t>Phase 3: Operational Deployment (6+ Months)</a:t>
+            </a:r>
+          </a:p>
+          <a:p>
+            <a:pPr>
+              <a:spcAft>
+                <a:spcPts val="800"/>
+              </a:spcAft>
+              <a:defRPr sz="1300">
+                <a:solidFill>
+                  <a:srgbClr val="282828"/>
+                </a:solidFill>
+                <a:latin typeface="Arial"/>
+              </a:defRPr>
+            </a:pPr>
+            <a:r>
+              <a:t>• Integrate spatial imaging from Aditya-L1 SUIT or magnetograms to resolve active region spatial ambiguity.</a:t>
+            </a:r>
+            <a:br/>
+            <a:r>
+              <a:t>• Retrain models to predict flare magnitude class (C, M, or X-class).</a:t>
+            </a:r>
+            <a:br/>
+            <a:r>
+              <a:t>• Integrate alert feeds into the ISRO Space Situational Awareness Centre (SSAC).</a:t>
+            </a:r>
+          </a:p>
+        </p:txBody>
+      </p:sp>
+    </p:spTree>
+  </p:cSld>
+  <p:clrMapOvr>
+    <a:masterClrMapping/>
+  </p:clrMapOvr>
+</p:sld>
+</file>
+
+<file path=ppt/slides/slide11.xml><?xml version="1.0" encoding="utf-8"?>
+<p:sld xmlns:a="http://schemas.openxmlformats.org/drawingml/2006/main" xmlns:p="http://schemas.openxmlformats.org/presentationml/2006/main" xmlns:r="http://schemas.openxmlformats.org/officeDocument/2006/relationships">
+  <p:cSld>
+    <p:spTree>
+      <p:nvGrpSpPr>
+        <p:cNvPr id="1" name=""/>
+        <p:cNvGrpSpPr/>
+        <p:nvPr/>
+      </p:nvGrpSpPr>
+      <p:grpSpPr/>
+      <p:sp>
+        <p:nvSpPr>
+          <p:cNvPr id="2" name="Rectangle 1"/>
+          <p:cNvSpPr/>
+          <p:nvPr/>
+        </p:nvSpPr>
+        <p:spPr>
+          <a:xfrm>
+            <a:off x="0" y="0"/>
+            <a:ext cx="12188952" cy="6858000"/>
+          </a:xfrm>
+          <a:prstGeom prst="rect">
+            <a:avLst/>
+          </a:prstGeom>
+          <a:solidFill>
+            <a:srgbClr val="F5F7FA"/>
+          </a:solidFill>
+          <a:ln>
+            <a:noFill/>
+          </a:ln>
+        </p:spPr>
+        <p:style>
+          <a:lnRef idx="1">
+            <a:schemeClr val="accent1"/>
+          </a:lnRef>
+          <a:fillRef idx="3">
+            <a:schemeClr val="accent1"/>
+          </a:fillRef>
+          <a:effectRef idx="2">
+            <a:schemeClr val="accent1"/>
+          </a:effectRef>
+          <a:fontRef idx="minor">
+            <a:schemeClr val="lt1"/>
+          </a:fontRef>
+        </p:style>
+        <p:txBody>
+          <a:bodyPr rtlCol="0" anchor="ctr"/>
+          <a:lstStyle/>
+          <a:p>
+            <a:pPr algn="ctr"/>
+          </a:p>
+        </p:txBody>
+      </p:sp>
+      <p:sp>
+        <p:nvSpPr>
+          <p:cNvPr id="3" name="TextBox 2"/>
+          <p:cNvSpPr txBox="1"/>
+          <p:nvPr/>
+        </p:nvSpPr>
+        <p:spPr>
+          <a:xfrm>
+            <a:off x="685800" y="457200"/>
+            <a:ext cx="10817352" cy="731520"/>
+          </a:xfrm>
+          <a:prstGeom prst="rect">
+            <a:avLst/>
+          </a:prstGeom>
+          <a:noFill/>
+        </p:spPr>
+        <p:txBody>
+          <a:bodyPr wrap="square" lIns="0" tIns="0" rIns="0" bIns="0">
+            <a:spAutoFit/>
+          </a:bodyPr>
+          <a:lstStyle/>
+          <a:p>
+            <a:pPr>
+              <a:defRPr sz="3600" b="1">
+                <a:solidFill>
+                  <a:srgbClr val="002060"/>
+                </a:solidFill>
+                <a:latin typeface="Arial"/>
+              </a:defRPr>
+            </a:pPr>
+            <a:r>
+              <a:t>Team and Institution</a:t>
+            </a:r>
+          </a:p>
+        </p:txBody>
+      </p:sp>
+      <p:sp>
+        <p:nvSpPr>
+          <p:cNvPr id="4" name="Rectangle 3"/>
+          <p:cNvSpPr/>
+          <p:nvPr/>
+        </p:nvSpPr>
+        <p:spPr>
+          <a:xfrm>
+            <a:off x="685800" y="1234440"/>
+            <a:ext cx="10817352" cy="54864"/>
+          </a:xfrm>
+          <a:prstGeom prst="rect">
+            <a:avLst/>
+          </a:prstGeom>
+          <a:solidFill>
+            <a:srgbClr val="009664"/>
+          </a:solidFill>
+          <a:ln>
+            <a:noFill/>
+          </a:ln>
+        </p:spPr>
+        <p:style>
+          <a:lnRef idx="1">
+            <a:schemeClr val="accent1"/>
+          </a:lnRef>
+          <a:fillRef idx="3">
+            <a:schemeClr val="accent1"/>
+          </a:fillRef>
+          <a:effectRef idx="2">
+            <a:schemeClr val="accent1"/>
+          </a:effectRef>
+          <a:fontRef idx="minor">
+            <a:schemeClr val="lt1"/>
+          </a:fontRef>
+        </p:style>
+        <p:txBody>
+          <a:bodyPr rtlCol="0" anchor="ctr"/>
+          <a:lstStyle/>
+          <a:p>
+            <a:pPr algn="ctr"/>
+          </a:p>
+        </p:txBody>
+      </p:sp>
+      <p:sp>
+        <p:nvSpPr>
+          <p:cNvPr id="5" name="TextBox 4"/>
+          <p:cNvSpPr txBox="1"/>
+          <p:nvPr/>
+        </p:nvSpPr>
+        <p:spPr>
+          <a:xfrm>
+            <a:off x="685800" y="1645920"/>
+            <a:ext cx="10817352" cy="4389120"/>
+          </a:xfrm>
+          <a:prstGeom prst="rect">
+            <a:avLst/>
+          </a:prstGeom>
+          <a:noFill/>
+        </p:spPr>
+        <p:txBody>
+          <a:bodyPr wrap="square">
+            <a:spAutoFit/>
+          </a:bodyPr>
+          <a:lstStyle/>
+          <a:p>
+            <a:pPr>
+              <a:spcAft>
+                <a:spcPts val="1400"/>
+              </a:spcAft>
+              <a:defRPr sz="2200" b="1">
+                <a:solidFill>
+                  <a:srgbClr val="002060"/>
+                </a:solidFill>
+                <a:latin typeface="Arial"/>
+              </a:defRPr>
+            </a:pPr>
+            <a:r>
+              <a:t>Team: SolarSentinels</a:t>
+            </a:r>
+          </a:p>
+          <a:p>
+            <a:pPr>
+              <a:spcAft>
+                <a:spcPts val="200"/>
+              </a:spcAft>
+              <a:defRPr sz="1800" b="1">
+                <a:solidFill>
+                  <a:srgbClr val="009664"/>
+                </a:solidFill>
+                <a:latin typeface="Arial"/>
+              </a:defRPr>
+            </a:pPr>
+            <a:r>
+              <a:t>• Deep Shekhar Halder (Lead)</a:t>
+            </a:r>
+          </a:p>
+          <a:p>
+            <a:pPr>
+              <a:spcAft>
+                <a:spcPts val="1000"/>
+              </a:spcAft>
+              <a:defRPr sz="1500">
+                <a:solidFill>
+                  <a:srgbClr val="282828"/>
+                </a:solidFill>
+                <a:latin typeface="Arial"/>
+              </a:defRPr>
+            </a:pPr>
+            <a:r>
+              <a:t>  Algorithm design, data pipeline integration, and machine learning modeling.</a:t>
+            </a:r>
+          </a:p>
+          <a:p>
+            <a:pPr>
+              <a:spcAft>
+                <a:spcPts val="200"/>
+              </a:spcAft>
+              <a:defRPr sz="1800" b="1">
+                <a:solidFill>
+                  <a:srgbClr val="009664"/>
+                </a:solidFill>
+                <a:latin typeface="Arial"/>
+              </a:defRPr>
+            </a:pPr>
+            <a:r>
+              <a:t>• Mahalaxmi Macha</a:t>
+            </a:r>
+          </a:p>
+          <a:p>
+            <a:pPr>
+              <a:spcAft>
+                <a:spcPts val="1000"/>
+              </a:spcAft>
+              <a:defRPr sz="1500">
+                <a:solidFill>
+                  <a:srgbClr val="282828"/>
+                </a:solidFill>
+                <a:latin typeface="Arial"/>
+              </a:defRPr>
+            </a:pPr>
+            <a:r>
+              <a:t>  Telemetry preprocessing, metadata alignment, and nowcasting validation.</a:t>
+            </a:r>
+          </a:p>
+          <a:p>
+            <a:pPr>
+              <a:spcAft>
+                <a:spcPts val="200"/>
+              </a:spcAft>
+              <a:defRPr sz="1800" b="1">
+                <a:solidFill>
+                  <a:srgbClr val="009664"/>
+                </a:solidFill>
+                <a:latin typeface="Arial"/>
+              </a:defRPr>
+            </a:pPr>
+            <a:r>
+              <a:t>• Ashfaque Ahamed Khan</a:t>
+            </a:r>
+          </a:p>
+          <a:p>
+            <a:pPr>
+              <a:spcAft>
+                <a:spcPts val="1000"/>
+              </a:spcAft>
+              <a:defRPr sz="1500">
+                <a:solidFill>
+                  <a:srgbClr val="282828"/>
+                </a:solidFill>
+                <a:latin typeface="Arial"/>
+              </a:defRPr>
+            </a:pPr>
+            <a:r>
+              <a:t>  Cross-catalog benchmarking, NOAA GOES validation, and dashboard deployment.</a:t>
+            </a:r>
+          </a:p>
+          <a:p>
+            <a:br/>
+            <a:pPr>
+              <a:spcAft>
+                <a:spcPts val="800"/>
+              </a:spcAft>
+              <a:defRPr sz="2200" b="1">
+                <a:solidFill>
+                  <a:srgbClr val="002060"/>
+                </a:solidFill>
+                <a:latin typeface="Arial"/>
+              </a:defRPr>
+            </a:pPr>
+            <a:r>
+              <a:t>Institution</a:t>
+            </a:r>
+          </a:p>
+          <a:p>
+            <a:pPr>
+              <a:defRPr sz="1600">
+                <a:solidFill>
+                  <a:srgbClr val="282828"/>
+                </a:solidFill>
+                <a:latin typeface="Arial"/>
+              </a:defRPr>
+            </a:pPr>
+            <a:r>
+              <a:t>Adamas University, Kolkata</a:t>
+            </a:r>
+            <a:br/>
+            <a:r>
+              <a:t>Department of Computer Science and Engineering</a:t>
+            </a:r>
+          </a:p>
+        </p:txBody>
+      </p:sp>
+    </p:spTree>
+  </p:cSld>
+  <p:clrMapOvr>
+    <a:masterClrMapping/>
+  </p:clrMapOvr>
+</p:sld>
+</file>
+
+<file path=ppt/slides/slide12.xml><?xml version="1.0" encoding="utf-8"?>
+<p:sld xmlns:a="http://schemas.openxmlformats.org/drawingml/2006/main" xmlns:p="http://schemas.openxmlformats.org/presentationml/2006/main" xmlns:r="http://schemas.openxmlformats.org/officeDocument/2006/relationships">
+  <p:cSld>
+    <p:spTree>
+      <p:nvGrpSpPr>
+        <p:cNvPr id="1" name=""/>
+        <p:cNvGrpSpPr/>
+        <p:nvPr/>
+      </p:nvGrpSpPr>
+      <p:grpSpPr/>
+      <p:sp>
+        <p:nvSpPr>
+          <p:cNvPr id="2" name="Rectangle 1"/>
+          <p:cNvSpPr/>
+          <p:nvPr/>
+        </p:nvSpPr>
+        <p:spPr>
+          <a:xfrm>
+            <a:off x="0" y="0"/>
+            <a:ext cx="12188952" cy="6858000"/>
+          </a:xfrm>
+          <a:prstGeom prst="rect">
+            <a:avLst/>
+          </a:prstGeom>
+          <a:solidFill>
+            <a:srgbClr val="F5F7FA"/>
+          </a:solidFill>
+          <a:ln>
+            <a:noFill/>
+          </a:ln>
+        </p:spPr>
+        <p:style>
+          <a:lnRef idx="1">
+            <a:schemeClr val="accent1"/>
+          </a:lnRef>
+          <a:fillRef idx="3">
+            <a:schemeClr val="accent1"/>
+          </a:fillRef>
+          <a:effectRef idx="2">
+            <a:schemeClr val="accent1"/>
+          </a:effectRef>
+          <a:fontRef idx="minor">
+            <a:schemeClr val="lt1"/>
+          </a:fontRef>
+        </p:style>
+        <p:txBody>
+          <a:bodyPr rtlCol="0" anchor="ctr"/>
+          <a:lstStyle/>
+          <a:p>
+            <a:pPr algn="ctr"/>
+          </a:p>
+        </p:txBody>
+      </p:sp>
+      <p:sp>
+        <p:nvSpPr>
+          <p:cNvPr id="3" name="TextBox 2"/>
+          <p:cNvSpPr txBox="1"/>
+          <p:nvPr/>
+        </p:nvSpPr>
+        <p:spPr>
+          <a:xfrm>
+            <a:off x="685800" y="457200"/>
+            <a:ext cx="10817352" cy="731520"/>
+          </a:xfrm>
+          <a:prstGeom prst="rect">
+            <a:avLst/>
+          </a:prstGeom>
+          <a:noFill/>
+        </p:spPr>
+        <p:txBody>
+          <a:bodyPr wrap="square" lIns="0" tIns="0" rIns="0" bIns="0">
+            <a:spAutoFit/>
+          </a:bodyPr>
+          <a:lstStyle/>
+          <a:p>
+            <a:pPr>
+              <a:defRPr sz="3600" b="1">
+                <a:solidFill>
+                  <a:srgbClr val="002060"/>
+                </a:solidFill>
+                <a:latin typeface="Arial"/>
+              </a:defRPr>
+            </a:pPr>
+            <a:r>
               <a:t>References &amp; Next Steps</a:t>
             </a:r>
           </a:p>
@@ -4525,6 +5230,302 @@
 </file>
 
 <file path=ppt/slides/slide5.xml><?xml version="1.0" encoding="utf-8"?>
+<p:sld xmlns:a="http://schemas.openxmlformats.org/drawingml/2006/main" xmlns:p="http://schemas.openxmlformats.org/presentationml/2006/main" xmlns:r="http://schemas.openxmlformats.org/officeDocument/2006/relationships">
+  <p:cSld>
+    <p:spTree>
+      <p:nvGrpSpPr>
+        <p:cNvPr id="1" name=""/>
+        <p:cNvGrpSpPr/>
+        <p:nvPr/>
+      </p:nvGrpSpPr>
+      <p:grpSpPr/>
+      <p:sp>
+        <p:nvSpPr>
+          <p:cNvPr id="2" name="Rectangle 1"/>
+          <p:cNvSpPr/>
+          <p:nvPr/>
+        </p:nvSpPr>
+        <p:spPr>
+          <a:xfrm>
+            <a:off x="0" y="0"/>
+            <a:ext cx="12188952" cy="6858000"/>
+          </a:xfrm>
+          <a:prstGeom prst="rect">
+            <a:avLst/>
+          </a:prstGeom>
+          <a:solidFill>
+            <a:srgbClr val="F5F7FA"/>
+          </a:solidFill>
+          <a:ln>
+            <a:noFill/>
+          </a:ln>
+        </p:spPr>
+        <p:style>
+          <a:lnRef idx="1">
+            <a:schemeClr val="accent1"/>
+          </a:lnRef>
+          <a:fillRef idx="3">
+            <a:schemeClr val="accent1"/>
+          </a:fillRef>
+          <a:effectRef idx="2">
+            <a:schemeClr val="accent1"/>
+          </a:effectRef>
+          <a:fontRef idx="minor">
+            <a:schemeClr val="lt1"/>
+          </a:fontRef>
+        </p:style>
+        <p:txBody>
+          <a:bodyPr rtlCol="0" anchor="ctr"/>
+          <a:lstStyle/>
+          <a:p>
+            <a:pPr algn="ctr"/>
+          </a:p>
+        </p:txBody>
+      </p:sp>
+      <p:sp>
+        <p:nvSpPr>
+          <p:cNvPr id="3" name="TextBox 2"/>
+          <p:cNvSpPr txBox="1"/>
+          <p:nvPr/>
+        </p:nvSpPr>
+        <p:spPr>
+          <a:xfrm>
+            <a:off x="685800" y="457200"/>
+            <a:ext cx="10817352" cy="731520"/>
+          </a:xfrm>
+          <a:prstGeom prst="rect">
+            <a:avLst/>
+          </a:prstGeom>
+          <a:noFill/>
+        </p:spPr>
+        <p:txBody>
+          <a:bodyPr wrap="square" lIns="0" tIns="0" rIns="0" bIns="0">
+            <a:spAutoFit/>
+          </a:bodyPr>
+          <a:lstStyle/>
+          <a:p>
+            <a:pPr>
+              <a:defRPr sz="3600" b="1">
+                <a:solidFill>
+                  <a:srgbClr val="002060"/>
+                </a:solidFill>
+                <a:latin typeface="Arial"/>
+              </a:defRPr>
+            </a:pPr>
+            <a:r>
+              <a:t>Real-Time Telemetry &amp; Event Detection Visuals</a:t>
+            </a:r>
+          </a:p>
+        </p:txBody>
+      </p:sp>
+      <p:sp>
+        <p:nvSpPr>
+          <p:cNvPr id="4" name="Rectangle 3"/>
+          <p:cNvSpPr/>
+          <p:nvPr/>
+        </p:nvSpPr>
+        <p:spPr>
+          <a:xfrm>
+            <a:off x="685800" y="1234440"/>
+            <a:ext cx="10817352" cy="54864"/>
+          </a:xfrm>
+          <a:prstGeom prst="rect">
+            <a:avLst/>
+          </a:prstGeom>
+          <a:solidFill>
+            <a:srgbClr val="009664"/>
+          </a:solidFill>
+          <a:ln>
+            <a:noFill/>
+          </a:ln>
+        </p:spPr>
+        <p:style>
+          <a:lnRef idx="1">
+            <a:schemeClr val="accent1"/>
+          </a:lnRef>
+          <a:fillRef idx="3">
+            <a:schemeClr val="accent1"/>
+          </a:fillRef>
+          <a:effectRef idx="2">
+            <a:schemeClr val="accent1"/>
+          </a:effectRef>
+          <a:fontRef idx="minor">
+            <a:schemeClr val="lt1"/>
+          </a:fontRef>
+        </p:style>
+        <p:txBody>
+          <a:bodyPr rtlCol="0" anchor="ctr"/>
+          <a:lstStyle/>
+          <a:p>
+            <a:pPr algn="ctr"/>
+          </a:p>
+        </p:txBody>
+      </p:sp>
+      <p:sp>
+        <p:nvSpPr>
+          <p:cNvPr id="5" name="TextBox 4"/>
+          <p:cNvSpPr txBox="1"/>
+          <p:nvPr/>
+        </p:nvSpPr>
+        <p:spPr>
+          <a:xfrm>
+            <a:off x="685800" y="1371600"/>
+            <a:ext cx="10817352" cy="731520"/>
+          </a:xfrm>
+          <a:prstGeom prst="rect">
+            <a:avLst/>
+          </a:prstGeom>
+          <a:noFill/>
+        </p:spPr>
+        <p:txBody>
+          <a:bodyPr wrap="square">
+            <a:spAutoFit/>
+          </a:bodyPr>
+          <a:lstStyle/>
+          <a:p>
+            <a:pPr>
+              <a:defRPr sz="1400">
+                <a:solidFill>
+                  <a:srgbClr val="282828"/>
+                </a:solidFill>
+                <a:latin typeface="Arial"/>
+              </a:defRPr>
+            </a:pPr>
+            <a:r>
+              <a:t>High-cadence X-ray telemetry from Aditya-L1's SoLEXS instrument analyzed by our causal nowcasting pipeline. The plots below illustrate the raw count rates, dynamic thresholding, and identified solar flare events.</a:t>
+            </a:r>
+          </a:p>
+        </p:txBody>
+      </p:sp>
+      <p:pic>
+        <p:nvPicPr>
+          <p:cNvPr id="6" name="Picture 5" descr="solexs_plot_zoom.png"/>
+          <p:cNvPicPr>
+            <a:picLocks noChangeAspect="1"/>
+          </p:cNvPicPr>
+          <p:nvPr/>
+        </p:nvPicPr>
+        <p:blipFill>
+          <a:blip r:embed="rId2"/>
+          <a:stretch>
+            <a:fillRect/>
+          </a:stretch>
+        </p:blipFill>
+        <p:spPr>
+          <a:xfrm>
+            <a:off x="685800" y="2011680"/>
+            <a:ext cx="5120640" cy="3474720"/>
+          </a:xfrm>
+          <a:prstGeom prst="rect">
+            <a:avLst/>
+          </a:prstGeom>
+        </p:spPr>
+      </p:pic>
+      <p:sp>
+        <p:nvSpPr>
+          <p:cNvPr id="7" name="TextBox 6"/>
+          <p:cNvSpPr txBox="1"/>
+          <p:nvPr/>
+        </p:nvSpPr>
+        <p:spPr>
+          <a:xfrm>
+            <a:off x="685800" y="5577840"/>
+            <a:ext cx="5120640" cy="731520"/>
+          </a:xfrm>
+          <a:prstGeom prst="rect">
+            <a:avLst/>
+          </a:prstGeom>
+          <a:noFill/>
+        </p:spPr>
+        <p:txBody>
+          <a:bodyPr wrap="square">
+            <a:spAutoFit/>
+          </a:bodyPr>
+          <a:lstStyle/>
+          <a:p>
+            <a:pPr algn="ctr">
+              <a:defRPr sz="1100" i="1">
+                <a:solidFill>
+                  <a:srgbClr val="282828"/>
+                </a:solidFill>
+                <a:latin typeface="Arial"/>
+              </a:defRPr>
+            </a:pPr>
+            <a:r>
+              <a:t>Figure 1: SoLEXS soft X-ray telemetry zoom showing the rolling median baseline and the dynamic nowcasting threshold.</a:t>
+            </a:r>
+          </a:p>
+        </p:txBody>
+      </p:sp>
+      <p:pic>
+        <p:nvPicPr>
+          <p:cNvPr id="8" name="Picture 7" descr="solexs_event_zoom.png"/>
+          <p:cNvPicPr>
+            <a:picLocks noChangeAspect="1"/>
+          </p:cNvPicPr>
+          <p:nvPr/>
+        </p:nvPicPr>
+        <p:blipFill>
+          <a:blip r:embed="rId3"/>
+          <a:stretch>
+            <a:fillRect/>
+          </a:stretch>
+        </p:blipFill>
+        <p:spPr>
+          <a:xfrm>
+            <a:off x="6382512" y="2011680"/>
+            <a:ext cx="5120640" cy="3474720"/>
+          </a:xfrm>
+          <a:prstGeom prst="rect">
+            <a:avLst/>
+          </a:prstGeom>
+        </p:spPr>
+      </p:pic>
+      <p:sp>
+        <p:nvSpPr>
+          <p:cNvPr id="9" name="TextBox 8"/>
+          <p:cNvSpPr txBox="1"/>
+          <p:nvPr/>
+        </p:nvSpPr>
+        <p:spPr>
+          <a:xfrm>
+            <a:off x="6382512" y="5577840"/>
+            <a:ext cx="5120640" cy="731520"/>
+          </a:xfrm>
+          <a:prstGeom prst="rect">
+            <a:avLst/>
+          </a:prstGeom>
+          <a:noFill/>
+        </p:spPr>
+        <p:txBody>
+          <a:bodyPr wrap="square">
+            <a:spAutoFit/>
+          </a:bodyPr>
+          <a:lstStyle/>
+          <a:p>
+            <a:pPr algn="ctr">
+              <a:defRPr sz="1100" i="1">
+                <a:solidFill>
+                  <a:srgbClr val="282828"/>
+                </a:solidFill>
+                <a:latin typeface="Arial"/>
+              </a:defRPr>
+            </a:pPr>
+            <a:r>
+              <a:t>Figure 2: Zoomed-in view of a detected solar flare event, showing precise onset, peak, and decay phases.</a:t>
+            </a:r>
+          </a:p>
+        </p:txBody>
+      </p:sp>
+    </p:spTree>
+  </p:cSld>
+  <p:clrMapOvr>
+    <a:masterClrMapping/>
+  </p:clrMapOvr>
+</p:sld>
+</file>
+
+<file path=ppt/slides/slide6.xml><?xml version="1.0" encoding="utf-8"?>
 <p:sld xmlns:a="http://schemas.openxmlformats.org/drawingml/2006/main" xmlns:p="http://schemas.openxmlformats.org/presentationml/2006/main" xmlns:r="http://schemas.openxmlformats.org/officeDocument/2006/relationships">
   <p:cSld>
     <p:spTree>
@@ -5204,266 +6205,6 @@
 </p:sld>
 </file>
 
-<file path=ppt/slides/slide6.xml><?xml version="1.0" encoding="utf-8"?>
-<p:sld xmlns:a="http://schemas.openxmlformats.org/drawingml/2006/main" xmlns:p="http://schemas.openxmlformats.org/presentationml/2006/main" xmlns:r="http://schemas.openxmlformats.org/officeDocument/2006/relationships">
-  <p:cSld>
-    <p:spTree>
-      <p:nvGrpSpPr>
-        <p:cNvPr id="1" name=""/>
-        <p:cNvGrpSpPr/>
-        <p:nvPr/>
-      </p:nvGrpSpPr>
-      <p:grpSpPr/>
-      <p:sp>
-        <p:nvSpPr>
-          <p:cNvPr id="2" name="Rectangle 1"/>
-          <p:cNvSpPr/>
-          <p:nvPr/>
-        </p:nvSpPr>
-        <p:spPr>
-          <a:xfrm>
-            <a:off x="0" y="0"/>
-            <a:ext cx="12188952" cy="6858000"/>
-          </a:xfrm>
-          <a:prstGeom prst="rect">
-            <a:avLst/>
-          </a:prstGeom>
-          <a:solidFill>
-            <a:srgbClr val="F5F7FA"/>
-          </a:solidFill>
-          <a:ln>
-            <a:noFill/>
-          </a:ln>
-        </p:spPr>
-        <p:style>
-          <a:lnRef idx="1">
-            <a:schemeClr val="accent1"/>
-          </a:lnRef>
-          <a:fillRef idx="3">
-            <a:schemeClr val="accent1"/>
-          </a:fillRef>
-          <a:effectRef idx="2">
-            <a:schemeClr val="accent1"/>
-          </a:effectRef>
-          <a:fontRef idx="minor">
-            <a:schemeClr val="lt1"/>
-          </a:fontRef>
-        </p:style>
-        <p:txBody>
-          <a:bodyPr rtlCol="0" anchor="ctr"/>
-          <a:lstStyle/>
-          <a:p>
-            <a:pPr algn="ctr"/>
-          </a:p>
-        </p:txBody>
-      </p:sp>
-      <p:sp>
-        <p:nvSpPr>
-          <p:cNvPr id="3" name="TextBox 2"/>
-          <p:cNvSpPr txBox="1"/>
-          <p:nvPr/>
-        </p:nvSpPr>
-        <p:spPr>
-          <a:xfrm>
-            <a:off x="685800" y="457200"/>
-            <a:ext cx="10817352" cy="731520"/>
-          </a:xfrm>
-          <a:prstGeom prst="rect">
-            <a:avLst/>
-          </a:prstGeom>
-          <a:noFill/>
-        </p:spPr>
-        <p:txBody>
-          <a:bodyPr wrap="square" lIns="0" tIns="0" rIns="0" bIns="0">
-            <a:spAutoFit/>
-          </a:bodyPr>
-          <a:lstStyle/>
-          <a:p>
-            <a:pPr>
-              <a:defRPr sz="3600" b="1">
-                <a:solidFill>
-                  <a:srgbClr val="002060"/>
-                </a:solidFill>
-                <a:latin typeface="Arial"/>
-              </a:defRPr>
-            </a:pPr>
-            <a:r>
-              <a:t>Innovation and Technical Merit</a:t>
-            </a:r>
-          </a:p>
-        </p:txBody>
-      </p:sp>
-      <p:sp>
-        <p:nvSpPr>
-          <p:cNvPr id="4" name="Rectangle 3"/>
-          <p:cNvSpPr/>
-          <p:nvPr/>
-        </p:nvSpPr>
-        <p:spPr>
-          <a:xfrm>
-            <a:off x="685800" y="1234440"/>
-            <a:ext cx="10817352" cy="54864"/>
-          </a:xfrm>
-          <a:prstGeom prst="rect">
-            <a:avLst/>
-          </a:prstGeom>
-          <a:solidFill>
-            <a:srgbClr val="009664"/>
-          </a:solidFill>
-          <a:ln>
-            <a:noFill/>
-          </a:ln>
-        </p:spPr>
-        <p:style>
-          <a:lnRef idx="1">
-            <a:schemeClr val="accent1"/>
-          </a:lnRef>
-          <a:fillRef idx="3">
-            <a:schemeClr val="accent1"/>
-          </a:fillRef>
-          <a:effectRef idx="2">
-            <a:schemeClr val="accent1"/>
-          </a:effectRef>
-          <a:fontRef idx="minor">
-            <a:schemeClr val="lt1"/>
-          </a:fontRef>
-        </p:style>
-        <p:txBody>
-          <a:bodyPr rtlCol="0" anchor="ctr"/>
-          <a:lstStyle/>
-          <a:p>
-            <a:pPr algn="ctr"/>
-          </a:p>
-        </p:txBody>
-      </p:sp>
-      <p:sp>
-        <p:nvSpPr>
-          <p:cNvPr id="5" name="TextBox 4"/>
-          <p:cNvSpPr txBox="1"/>
-          <p:nvPr/>
-        </p:nvSpPr>
-        <p:spPr>
-          <a:xfrm>
-            <a:off x="685800" y="1645920"/>
-            <a:ext cx="10817352" cy="4389120"/>
-          </a:xfrm>
-          <a:prstGeom prst="rect">
-            <a:avLst/>
-          </a:prstGeom>
-          <a:noFill/>
-        </p:spPr>
-        <p:txBody>
-          <a:bodyPr wrap="square">
-            <a:spAutoFit/>
-          </a:bodyPr>
-          <a:lstStyle/>
-          <a:p/>
-          <a:p>
-            <a:pPr>
-              <a:spcAft>
-                <a:spcPts val="400"/>
-              </a:spcAft>
-              <a:defRPr sz="1800" b="1">
-                <a:solidFill>
-                  <a:srgbClr val="002060"/>
-                </a:solidFill>
-                <a:latin typeface="Arial"/>
-              </a:defRPr>
-            </a:pPr>
-            <a:r>
-              <a:t>■ Causal Moving Baselines</a:t>
-            </a:r>
-          </a:p>
-          <a:p>
-            <a:pPr>
-              <a:spcAft>
-                <a:spcPts val="1600"/>
-              </a:spcAft>
-              <a:defRPr sz="1500">
-                <a:solidFill>
-                  <a:srgbClr val="282828"/>
-                </a:solidFill>
-                <a:latin typeface="Arial"/>
-              </a:defRPr>
-            </a:pPr>
-            <a:r>
-              <a:t>Standard automated flare detectors use centered smoothing windows (incorporating future time-steps), making them undeployable in real-time. We implement a strictly causal rolling baseline (shifting past-only windows) to guarantee our nowcasting and forecasting models remain fully compatible with live spacecraft telemetry.</a:t>
-            </a:r>
-          </a:p>
-          <a:p>
-            <a:pPr>
-              <a:spcAft>
-                <a:spcPts val="400"/>
-              </a:spcAft>
-              <a:defRPr sz="1800" b="1">
-                <a:solidFill>
-                  <a:srgbClr val="002060"/>
-                </a:solidFill>
-                <a:latin typeface="Arial"/>
-              </a:defRPr>
-            </a:pPr>
-            <a:r>
-              <a:t>■ Raw Multi-Instrument X-ray Fusion</a:t>
-            </a:r>
-          </a:p>
-          <a:p>
-            <a:pPr>
-              <a:spcAft>
-                <a:spcPts val="1600"/>
-              </a:spcAft>
-              <a:defRPr sz="1500">
-                <a:solidFill>
-                  <a:srgbClr val="282828"/>
-                </a:solidFill>
-                <a:latin typeface="Arial"/>
-              </a:defRPr>
-            </a:pPr>
-            <a:r>
-              <a:t>Prior work treats SoLEXS (SXR, thermal) and HEL1OS (HXR, non-thermal) as separate post-detection catalogs. We align the raw 1-second cadence time-series during their overlap window (259,071 shared timestamps) and compute the Spectral Hardness Ratio directly in the feature space.</a:t>
-            </a:r>
-          </a:p>
-          <a:p>
-            <a:pPr>
-              <a:spcAft>
-                <a:spcPts val="400"/>
-              </a:spcAft>
-              <a:defRPr sz="1800" b="1">
-                <a:solidFill>
-                  <a:srgbClr val="002060"/>
-                </a:solidFill>
-                <a:latin typeface="Arial"/>
-              </a:defRPr>
-            </a:pPr>
-            <a:r>
-              <a:t>■ Explainable Space Weather Dashboard</a:t>
-            </a:r>
-          </a:p>
-          <a:p>
-            <a:pPr>
-              <a:spcAft>
-                <a:spcPts val="1600"/>
-              </a:spcAft>
-              <a:defRPr sz="1500">
-                <a:solidFill>
-                  <a:srgbClr val="282828"/>
-                </a:solidFill>
-                <a:latin typeface="Arial"/>
-              </a:defRPr>
-            </a:pPr>
-            <a:r>
-              <a:t>Developed an operator-focused dashboard that runs in &lt;100ms on standard hardware, exposing live count rates, threat alerts (Green/Yellow/Red), and forecasting probabilities. The dashboard can be securely accessed remotely using localtunnel without any code changes.</a:t>
-            </a:r>
-          </a:p>
-        </p:txBody>
-      </p:sp>
-    </p:spTree>
-  </p:cSld>
-  <p:clrMapOvr>
-    <a:masterClrMapping/>
-  </p:clrMapOvr>
-</p:sld>
-</file>
-
 <file path=ppt/slides/slide7.xml><?xml version="1.0" encoding="utf-8"?>
 <p:sld xmlns:a="http://schemas.openxmlformats.org/drawingml/2006/main" xmlns:p="http://schemas.openxmlformats.org/presentationml/2006/main" xmlns:r="http://schemas.openxmlformats.org/officeDocument/2006/relationships">
   <p:cSld>
@@ -5548,7 +6289,7 @@
               </a:defRPr>
             </a:pPr>
             <a:r>
-              <a:t>Technical Limitations &amp; Gaps</a:t>
+              <a:t>Case Study: Microflare Discovery</a:t>
             </a:r>
           </a:p>
         </p:txBody>
@@ -5605,7 +6346,7 @@
         <p:spPr>
           <a:xfrm>
             <a:off x="685800" y="1645920"/>
-            <a:ext cx="10817352" cy="4389120"/>
+            <a:ext cx="5120640" cy="4389120"/>
           </a:xfrm>
           <a:prstGeom prst="rect">
             <a:avLst/>
@@ -5620,9 +6361,25 @@
           <a:p>
             <a:pPr>
               <a:spcAft>
-                <a:spcPts val="2000"/>
+                <a:spcPts val="1400"/>
               </a:spcAft>
-              <a:defRPr sz="1600">
+              <a:defRPr sz="2200" b="1">
+                <a:solidFill>
+                  <a:srgbClr val="002060"/>
+                </a:solidFill>
+                <a:latin typeface="Arial"/>
+              </a:defRPr>
+            </a:pPr>
+            <a:r>
+              <a:t>Discovering Sub-Threshold Events</a:t>
+            </a:r>
+          </a:p>
+          <a:p>
+            <a:pPr>
+              <a:spcAft>
+                <a:spcPts val="1200"/>
+              </a:spcAft>
+              <a:defRPr sz="1400">
                 <a:solidFill>
                   <a:srgbClr val="282828"/>
                 </a:solidFill>
@@ -5630,31 +6387,31 @@
               </a:defRPr>
             </a:pPr>
             <a:r>
-              <a:t>To demonstrate scientific maturity, we identify the operational limitations of our proof-of-concept and how they will be resolved:</a:t>
+              <a:t>• Superior Instrument Sensitivity: Aditya-L1 SoLEXS captures faint solar activity due to its low-energy threshold and high spectral resolution.</a:t>
             </a:r>
           </a:p>
           <a:p>
             <a:pPr>
               <a:spcAft>
-                <a:spcPts val="400"/>
+                <a:spcPts val="1200"/>
               </a:spcAft>
-              <a:defRPr sz="1800" b="1">
-                <a:solidFill>
-                  <a:srgbClr val="002060"/>
-                </a:solidFill>
-                <a:latin typeface="Arial"/>
-              </a:defRPr>
-            </a:pPr>
-            <a:r>
-              <a:t>■ Short Observation Window</a:t>
+              <a:defRPr sz="1400">
+                <a:solidFill>
+                  <a:srgbClr val="282828"/>
+                </a:solidFill>
+                <a:latin typeface="Arial"/>
+              </a:defRPr>
+            </a:pPr>
+            <a:r>
+              <a:t>• The June 10 Event: On June 10, 2026, at 23:46 UTC, our causal nowcasting algorithm flagged a highly structured, 679-second duration event.</a:t>
             </a:r>
           </a:p>
           <a:p>
             <a:pPr>
               <a:spcAft>
-                <a:spcPts val="1600"/>
+                <a:spcPts val="1200"/>
               </a:spcAft>
-              <a:defRPr sz="1500">
+              <a:defRPr sz="1400">
                 <a:solidFill>
                   <a:srgbClr val="282828"/>
                 </a:solidFill>
@@ -5662,31 +6419,15 @@
               </a:defRPr>
             </a:pPr>
             <a:r>
-              <a:t>The current 6-day telemetry dataset contains only 16 distinct flare events. This limits the training data available for deep machine learning, which we mitigate using balanced class weights but must scale up using multi-month archives.</a:t>
+              <a:t>• GOES Catalog Gap: This event is completely absent from the official NOAA GOES flare catalog, confirming its status as a newly discovered microflare.</a:t>
             </a:r>
           </a:p>
           <a:p>
             <a:pPr>
               <a:spcAft>
-                <a:spcPts val="400"/>
+                <a:spcPts val="1200"/>
               </a:spcAft>
-              <a:defRPr sz="1800" b="1">
-                <a:solidFill>
-                  <a:srgbClr val="002060"/>
-                </a:solidFill>
-                <a:latin typeface="Arial"/>
-              </a:defRPr>
-            </a:pPr>
-            <a:r>
-              <a:t>■ Lack of Spacecraft Attitude Correction</a:t>
-            </a:r>
-          </a:p>
-          <a:p>
-            <a:pPr>
-              <a:spcAft>
-                <a:spcPts val="1600"/>
-              </a:spcAft>
-              <a:defRPr sz="1500">
+              <a:defRPr sz="1400">
                 <a:solidFill>
                   <a:srgbClr val="282828"/>
                 </a:solidFill>
@@ -5694,31 +6435,59 @@
               </a:defRPr>
             </a:pPr>
             <a:r>
-              <a:t>Collimator responses vary during spacecraft off-pointing or calibration maneuvers, affecting raw count rates. Ingesting spacecraft attitude telemetry is required to correct collimator area variations.</a:t>
-            </a:r>
-          </a:p>
-          <a:p>
-            <a:pPr>
-              <a:spcAft>
-                <a:spcPts val="400"/>
-              </a:spcAft>
-              <a:defRPr sz="1800" b="1">
-                <a:solidFill>
-                  <a:srgbClr val="002060"/>
-                </a:solidFill>
-                <a:latin typeface="Arial"/>
-              </a:defRPr>
-            </a:pPr>
-            <a:r>
-              <a:t>■ Dynamic Background Drift &amp; Calibration</a:t>
-            </a:r>
-          </a:p>
-          <a:p>
-            <a:pPr>
-              <a:spcAft>
-                <a:spcPts val="1600"/>
-              </a:spcAft>
-              <a:defRPr sz="1500">
+              <a:t>• Scientific Importance: Microflares are critical to solving the coronal heating problem, and their real-time detection validates our dynamic baseline approach.</a:t>
+            </a:r>
+          </a:p>
+        </p:txBody>
+      </p:sp>
+      <p:pic>
+        <p:nvPicPr>
+          <p:cNvPr id="6" name="Picture 5" descr="solexs_20260610_2346_event.png"/>
+          <p:cNvPicPr>
+            <a:picLocks noChangeAspect="1"/>
+          </p:cNvPicPr>
+          <p:nvPr/>
+        </p:nvPicPr>
+        <p:blipFill>
+          <a:blip r:embed="rId2"/>
+          <a:stretch>
+            <a:fillRect/>
+          </a:stretch>
+        </p:blipFill>
+        <p:spPr>
+          <a:xfrm>
+            <a:off x="6382512" y="1645920"/>
+            <a:ext cx="5120640" cy="3840480"/>
+          </a:xfrm>
+          <a:prstGeom prst="rect">
+            <a:avLst/>
+          </a:prstGeom>
+        </p:spPr>
+      </p:pic>
+      <p:sp>
+        <p:nvSpPr>
+          <p:cNvPr id="7" name="TextBox 6"/>
+          <p:cNvSpPr txBox="1"/>
+          <p:nvPr/>
+        </p:nvSpPr>
+        <p:spPr>
+          <a:xfrm>
+            <a:off x="6382512" y="5577840"/>
+            <a:ext cx="5120640" cy="731520"/>
+          </a:xfrm>
+          <a:prstGeom prst="rect">
+            <a:avLst/>
+          </a:prstGeom>
+          <a:noFill/>
+        </p:spPr>
+        <p:txBody>
+          <a:bodyPr wrap="square">
+            <a:spAutoFit/>
+          </a:bodyPr>
+          <a:lstStyle/>
+          <a:p>
+            <a:pPr algn="ctr">
+              <a:defRPr sz="1100" i="1">
                 <a:solidFill>
                   <a:srgbClr val="282828"/>
                 </a:solidFill>
@@ -5726,7 +6495,7 @@
               </a:defRPr>
             </a:pPr>
             <a:r>
-              <a:t>Non-solar particle backgrounds (cosmic rays) require dynamic cosmic-ray subtraction using auxiliary veto channels. Furthermore, converting raw counts to physical flux units ($photons/cm^2/s/keV$) requires incorporating Detector Response Matrices (DRMs) for real-time spectral fitting.</a:t>
+              <a:t>Figure 3: Microflare event detected by SoLEXS at 23:46 UTC on June 10, 2026 (679s duration, peak ~6,800 cps, absent from GOES).</a:t>
             </a:r>
           </a:p>
         </p:txBody>
@@ -5823,7 +6592,7 @@
               </a:defRPr>
             </a:pPr>
             <a:r>
-              <a:t>Development Roadmap</a:t>
+              <a:t>Innovation and Technical Merit</a:t>
             </a:r>
           </a:p>
         </p:txBody>
@@ -5873,66 +6642,48 @@
       </p:sp>
       <p:sp>
         <p:nvSpPr>
-          <p:cNvPr id="5" name="Rounded Rectangle 4"/>
-          <p:cNvSpPr/>
+          <p:cNvPr id="5" name="TextBox 4"/>
+          <p:cNvSpPr txBox="1"/>
           <p:nvPr/>
         </p:nvSpPr>
         <p:spPr>
           <a:xfrm>
             <a:off x="685800" y="1645920"/>
-            <a:ext cx="3474720" cy="4389120"/>
-          </a:xfrm>
-          <a:prstGeom prst="roundRect">
+            <a:ext cx="10817352" cy="4389120"/>
+          </a:xfrm>
+          <a:prstGeom prst="rect">
             <a:avLst/>
           </a:prstGeom>
-          <a:solidFill>
-            <a:srgbClr val="FFFFFF"/>
-          </a:solidFill>
-          <a:ln w="19050">
-            <a:solidFill>
-              <a:srgbClr val="009664"/>
-            </a:solidFill>
-          </a:ln>
-        </p:spPr>
-        <p:style>
-          <a:lnRef idx="1">
-            <a:schemeClr val="accent1"/>
-          </a:lnRef>
-          <a:fillRef idx="3">
-            <a:schemeClr val="accent1"/>
-          </a:fillRef>
-          <a:effectRef idx="2">
-            <a:schemeClr val="accent1"/>
-          </a:effectRef>
-          <a:fontRef idx="minor">
-            <a:schemeClr val="lt1"/>
-          </a:fontRef>
-        </p:style>
-        <p:txBody>
-          <a:bodyPr rtlCol="0" anchor="ctr" wrap="square" lIns="182880" rIns="182880" tIns="182880" bIns="182880"/>
-          <a:lstStyle/>
-          <a:p>
-            <a:pPr algn="ctr">
+          <a:noFill/>
+        </p:spPr>
+        <p:txBody>
+          <a:bodyPr wrap="square">
+            <a:spAutoFit/>
+          </a:bodyPr>
+          <a:lstStyle/>
+          <a:p/>
+          <a:p>
+            <a:pPr>
               <a:spcAft>
-                <a:spcPts val="1200"/>
+                <a:spcPts val="400"/>
               </a:spcAft>
-              <a:defRPr sz="1600" b="1">
-                <a:solidFill>
-                  <a:srgbClr val="009664"/>
-                </a:solidFill>
-                <a:latin typeface="Arial"/>
-              </a:defRPr>
-            </a:pPr>
-            <a:r>
-              <a:t>Phase 1: Proof of Concept (Implemented)</a:t>
+              <a:defRPr sz="1800" b="1">
+                <a:solidFill>
+                  <a:srgbClr val="002060"/>
+                </a:solidFill>
+                <a:latin typeface="Arial"/>
+              </a:defRPr>
+            </a:pPr>
+            <a:r>
+              <a:t>■ Causal Moving Baselines</a:t>
             </a:r>
           </a:p>
           <a:p>
             <a:pPr>
               <a:spcAft>
-                <a:spcPts val="800"/>
+                <a:spcPts val="1600"/>
               </a:spcAft>
-              <a:defRPr sz="1300">
+              <a:defRPr sz="1500">
                 <a:solidFill>
                   <a:srgbClr val="282828"/>
                 </a:solidFill>
@@ -5940,69 +6691,15 @@
               </a:defRPr>
             </a:pPr>
             <a:r>
-              <a:t>• Harmonized raw SoLEXS and HEL1OS FITS telemetry.</a:t>
-            </a:r>
-            <a:br/>
-            <a:r>
-              <a:t>• Built causal rolling nowcaster (93.2% recall vs. GOES).</a:t>
-            </a:r>
-            <a:br/>
-            <a:r>
-              <a:t>• Trained RandomForest forecasters using time-based holdout.</a:t>
-            </a:r>
-            <a:br/>
-            <a:r>
-              <a:t>• Deployed operator dashboard with live alerts &amp; localtunnel.</a:t>
-            </a:r>
-          </a:p>
-        </p:txBody>
-      </p:sp>
-      <p:sp>
-        <p:nvSpPr>
-          <p:cNvPr id="6" name="Rounded Rectangle 5"/>
-          <p:cNvSpPr/>
-          <p:nvPr/>
-        </p:nvSpPr>
-        <p:spPr>
-          <a:xfrm>
-            <a:off x="4343400" y="1645920"/>
-            <a:ext cx="3474720" cy="4389120"/>
-          </a:xfrm>
-          <a:prstGeom prst="roundRect">
-            <a:avLst/>
-          </a:prstGeom>
-          <a:solidFill>
-            <a:srgbClr val="FFFFFF"/>
-          </a:solidFill>
-          <a:ln w="19050">
-            <a:solidFill>
-              <a:srgbClr val="002060"/>
-            </a:solidFill>
-          </a:ln>
-        </p:spPr>
-        <p:style>
-          <a:lnRef idx="1">
-            <a:schemeClr val="accent1"/>
-          </a:lnRef>
-          <a:fillRef idx="3">
-            <a:schemeClr val="accent1"/>
-          </a:fillRef>
-          <a:effectRef idx="2">
-            <a:schemeClr val="accent1"/>
-          </a:effectRef>
-          <a:fontRef idx="minor">
-            <a:schemeClr val="lt1"/>
-          </a:fontRef>
-        </p:style>
-        <p:txBody>
-          <a:bodyPr rtlCol="0" anchor="ctr" wrap="square" lIns="182880" rIns="182880" tIns="182880" bIns="182880"/>
-          <a:lstStyle/>
-          <a:p>
-            <a:pPr algn="ctr">
+              <a:t>Standard automated flare detectors use centered smoothing windows (incorporating future time-steps), making them undeployable in real-time. We implement a strictly causal rolling baseline (shifting past-only windows) to guarantee our nowcasting and forecasting models remain fully compatible with live spacecraft telemetry.</a:t>
+            </a:r>
+          </a:p>
+          <a:p>
+            <a:pPr>
               <a:spcAft>
-                <a:spcPts val="1200"/>
+                <a:spcPts val="400"/>
               </a:spcAft>
-              <a:defRPr sz="1600" b="1">
+              <a:defRPr sz="1800" b="1">
                 <a:solidFill>
                   <a:srgbClr val="002060"/>
                 </a:solidFill>
@@ -6010,15 +6707,15 @@
               </a:defRPr>
             </a:pPr>
             <a:r>
-              <a:t>Phase 2: Prototype Scaling &amp; Calibration (2-3 Months)</a:t>
+              <a:t>■ Raw Multi-Instrument X-ray Fusion</a:t>
             </a:r>
           </a:p>
           <a:p>
             <a:pPr>
               <a:spcAft>
-                <a:spcPts val="800"/>
+                <a:spcPts val="1600"/>
               </a:spcAft>
-              <a:defRPr sz="1300">
+              <a:defRPr sz="1500">
                 <a:solidFill>
                   <a:srgbClr val="282828"/>
                 </a:solidFill>
@@ -6026,69 +6723,15 @@
               </a:defRPr>
             </a:pPr>
             <a:r>
-              <a:t>• Process multi-month Aditya-L1 archives (100-150+ major flares).</a:t>
-            </a:r>
-            <a:br/>
-            <a:r>
-              <a:t>• Integrate Detector Response Matrices (DRMs) for physical flux unit conversion.</a:t>
-            </a:r>
-            <a:br/>
-            <a:r>
-              <a:t>• Ingest spacecraft attitude telemetry for collimator area corrections.</a:t>
-            </a:r>
-            <a:br/>
-            <a:r>
-              <a:t>• Implement veto-detector background subtraction.</a:t>
-            </a:r>
-          </a:p>
-        </p:txBody>
-      </p:sp>
-      <p:sp>
-        <p:nvSpPr>
-          <p:cNvPr id="7" name="Rounded Rectangle 6"/>
-          <p:cNvSpPr/>
-          <p:nvPr/>
-        </p:nvSpPr>
-        <p:spPr>
-          <a:xfrm>
-            <a:off x="8001000" y="1645920"/>
-            <a:ext cx="3474720" cy="4389120"/>
-          </a:xfrm>
-          <a:prstGeom prst="roundRect">
-            <a:avLst/>
-          </a:prstGeom>
-          <a:solidFill>
-            <a:srgbClr val="FFFFFF"/>
-          </a:solidFill>
-          <a:ln w="19050">
-            <a:solidFill>
-              <a:srgbClr val="002060"/>
-            </a:solidFill>
-          </a:ln>
-        </p:spPr>
-        <p:style>
-          <a:lnRef idx="1">
-            <a:schemeClr val="accent1"/>
-          </a:lnRef>
-          <a:fillRef idx="3">
-            <a:schemeClr val="accent1"/>
-          </a:fillRef>
-          <a:effectRef idx="2">
-            <a:schemeClr val="accent1"/>
-          </a:effectRef>
-          <a:fontRef idx="minor">
-            <a:schemeClr val="lt1"/>
-          </a:fontRef>
-        </p:style>
-        <p:txBody>
-          <a:bodyPr rtlCol="0" anchor="ctr" wrap="square" lIns="182880" rIns="182880" tIns="182880" bIns="182880"/>
-          <a:lstStyle/>
-          <a:p>
-            <a:pPr algn="ctr">
+              <a:t>Prior work treats SoLEXS (SXR, thermal) and HEL1OS (HXR, non-thermal) as separate post-detection catalogs. We align the raw 1-second cadence time-series during their overlap window (259,071 shared timestamps) and compute the Spectral Hardness Ratio directly in the feature space.</a:t>
+            </a:r>
+          </a:p>
+          <a:p>
+            <a:pPr>
               <a:spcAft>
-                <a:spcPts val="1200"/>
+                <a:spcPts val="400"/>
               </a:spcAft>
-              <a:defRPr sz="1600" b="1">
+              <a:defRPr sz="1800" b="1">
                 <a:solidFill>
                   <a:srgbClr val="002060"/>
                 </a:solidFill>
@@ -6096,15 +6739,15 @@
               </a:defRPr>
             </a:pPr>
             <a:r>
-              <a:t>Phase 3: Operational Deployment (6+ Months)</a:t>
+              <a:t>■ Explainable Space Weather Dashboard</a:t>
             </a:r>
           </a:p>
           <a:p>
             <a:pPr>
               <a:spcAft>
-                <a:spcPts val="800"/>
+                <a:spcPts val="1600"/>
               </a:spcAft>
-              <a:defRPr sz="1300">
+              <a:defRPr sz="1500">
                 <a:solidFill>
                   <a:srgbClr val="282828"/>
                 </a:solidFill>
@@ -6112,15 +6755,7 @@
               </a:defRPr>
             </a:pPr>
             <a:r>
-              <a:t>• Integrate spatial imaging from Aditya-L1 SUIT or magnetograms to resolve active region spatial ambiguity.</a:t>
-            </a:r>
-            <a:br/>
-            <a:r>
-              <a:t>• Retrain models to predict flare magnitude class (C, M, or X-class).</a:t>
-            </a:r>
-            <a:br/>
-            <a:r>
-              <a:t>• Integrate alert feeds into the ISRO Space Situational Awareness Centre (SSAC).</a:t>
+              <a:t>Developed an operator-focused dashboard that runs in &lt;100ms on standard hardware, exposing live count rates, threat alerts (Green/Yellow/Red), and forecasting probabilities. The dashboard can be securely accessed remotely using localtunnel without any code changes.</a:t>
             </a:r>
           </a:p>
         </p:txBody>
@@ -6217,7 +6852,7 @@
               </a:defRPr>
             </a:pPr>
             <a:r>
-              <a:t>Team and Institution</a:t>
+              <a:t>Technical Limitations &amp; Gaps</a:t>
             </a:r>
           </a:p>
         </p:txBody>
@@ -6289,39 +6924,39 @@
           <a:p>
             <a:pPr>
               <a:spcAft>
-                <a:spcPts val="1400"/>
+                <a:spcPts val="2000"/>
               </a:spcAft>
-              <a:defRPr sz="2200" b="1">
-                <a:solidFill>
-                  <a:srgbClr val="002060"/>
-                </a:solidFill>
-                <a:latin typeface="Arial"/>
-              </a:defRPr>
-            </a:pPr>
-            <a:r>
-              <a:t>Team: SolarSentinels</a:t>
+              <a:defRPr sz="1600">
+                <a:solidFill>
+                  <a:srgbClr val="282828"/>
+                </a:solidFill>
+                <a:latin typeface="Arial"/>
+              </a:defRPr>
+            </a:pPr>
+            <a:r>
+              <a:t>To demonstrate scientific maturity, we identify the operational limitations of our proof-of-concept and how they will be resolved:</a:t>
             </a:r>
           </a:p>
           <a:p>
             <a:pPr>
               <a:spcAft>
-                <a:spcPts val="200"/>
+                <a:spcPts val="400"/>
               </a:spcAft>
               <a:defRPr sz="1800" b="1">
                 <a:solidFill>
-                  <a:srgbClr val="009664"/>
-                </a:solidFill>
-                <a:latin typeface="Arial"/>
-              </a:defRPr>
-            </a:pPr>
-            <a:r>
-              <a:t>• Deep Shekhar Halder (Lead)</a:t>
+                  <a:srgbClr val="002060"/>
+                </a:solidFill>
+                <a:latin typeface="Arial"/>
+              </a:defRPr>
+            </a:pPr>
+            <a:r>
+              <a:t>■ Short Observation Window</a:t>
             </a:r>
           </a:p>
           <a:p>
             <a:pPr>
               <a:spcAft>
-                <a:spcPts val="1000"/>
+                <a:spcPts val="1600"/>
               </a:spcAft>
               <a:defRPr sz="1500">
                 <a:solidFill>
@@ -6331,29 +6966,29 @@
               </a:defRPr>
             </a:pPr>
             <a:r>
-              <a:t>  Algorithm design, data pipeline integration, and machine learning modeling.</a:t>
+              <a:t>The current 6-day telemetry dataset contains only 16 distinct flare events. This limits the training data available for deep machine learning, which we mitigate using balanced class weights but must scale up using multi-month archives.</a:t>
             </a:r>
           </a:p>
           <a:p>
             <a:pPr>
               <a:spcAft>
-                <a:spcPts val="200"/>
+                <a:spcPts val="400"/>
               </a:spcAft>
               <a:defRPr sz="1800" b="1">
                 <a:solidFill>
-                  <a:srgbClr val="009664"/>
-                </a:solidFill>
-                <a:latin typeface="Arial"/>
-              </a:defRPr>
-            </a:pPr>
-            <a:r>
-              <a:t>• Mahalaxmi Macha</a:t>
+                  <a:srgbClr val="002060"/>
+                </a:solidFill>
+                <a:latin typeface="Arial"/>
+              </a:defRPr>
+            </a:pPr>
+            <a:r>
+              <a:t>■ Lack of Spacecraft Attitude Correction</a:t>
             </a:r>
           </a:p>
           <a:p>
             <a:pPr>
               <a:spcAft>
-                <a:spcPts val="1000"/>
+                <a:spcPts val="1600"/>
               </a:spcAft>
               <a:defRPr sz="1500">
                 <a:solidFill>
@@ -6363,29 +6998,29 @@
               </a:defRPr>
             </a:pPr>
             <a:r>
-              <a:t>  Telemetry preprocessing, metadata alignment, and nowcasting validation.</a:t>
+              <a:t>Collimator responses vary during spacecraft off-pointing or calibration maneuvers, affecting raw count rates. Ingesting spacecraft attitude telemetry is required to correct collimator area variations.</a:t>
             </a:r>
           </a:p>
           <a:p>
             <a:pPr>
               <a:spcAft>
-                <a:spcPts val="200"/>
+                <a:spcPts val="400"/>
               </a:spcAft>
               <a:defRPr sz="1800" b="1">
                 <a:solidFill>
-                  <a:srgbClr val="009664"/>
-                </a:solidFill>
-                <a:latin typeface="Arial"/>
-              </a:defRPr>
-            </a:pPr>
-            <a:r>
-              <a:t>• Ashfaque Ahamed Khan</a:t>
+                  <a:srgbClr val="002060"/>
+                </a:solidFill>
+                <a:latin typeface="Arial"/>
+              </a:defRPr>
+            </a:pPr>
+            <a:r>
+              <a:t>■ Dynamic Background Drift &amp; Calibration</a:t>
             </a:r>
           </a:p>
           <a:p>
             <a:pPr>
               <a:spcAft>
-                <a:spcPts val="1000"/>
+                <a:spcPts val="1600"/>
               </a:spcAft>
               <a:defRPr sz="1500">
                 <a:solidFill>
@@ -6395,41 +7030,7 @@
               </a:defRPr>
             </a:pPr>
             <a:r>
-              <a:t>  Cross-catalog benchmarking, NOAA GOES validation, and dashboard deployment.</a:t>
-            </a:r>
-          </a:p>
-          <a:p>
-            <a:br/>
-            <a:pPr>
-              <a:spcAft>
-                <a:spcPts val="800"/>
-              </a:spcAft>
-              <a:defRPr sz="2200" b="1">
-                <a:solidFill>
-                  <a:srgbClr val="002060"/>
-                </a:solidFill>
-                <a:latin typeface="Arial"/>
-              </a:defRPr>
-            </a:pPr>
-            <a:r>
-              <a:t>Institution</a:t>
-            </a:r>
-          </a:p>
-          <a:p>
-            <a:pPr>
-              <a:defRPr sz="1600">
-                <a:solidFill>
-                  <a:srgbClr val="282828"/>
-                </a:solidFill>
-                <a:latin typeface="Arial"/>
-              </a:defRPr>
-            </a:pPr>
-            <a:r>
-              <a:t>Adamas University, Kolkata</a:t>
-            </a:r>
-            <a:br/>
-            <a:r>
-              <a:t>Department of Computer Science and Engineering</a:t>
+              <a:t>Non-solar particle backgrounds (cosmic rays) require dynamic cosmic-ray subtraction using auxiliary veto channels. Furthermore, converting raw counts to physical flux units ($photons/cm^2/s/keV$) requires incorporating Detector Response Matrices (DRMs) for real-time spectral fitting.</a:t>
             </a:r>
           </a:p>
         </p:txBody>

</xml_diff>

<commit_message>
Finalize SolarFlare dashboard, assets, and calibration dataset (excluding large zip)
</commit_message>
<xml_diff>
--- a/AdityaL1_SolarFlare_Presentation.pptx
+++ b/AdityaL1_SolarFlare_Presentation.pptx
@@ -3248,7 +3248,7 @@
               </a:defRPr>
             </a:pPr>
             <a:r>
-              <a:t>Team: SolarSentinels | Institution: Adamas University, Kolkata</a:t>
+              <a:t>Team: SuryaDrishti | Institution: Adamas University, Kolkata</a:t>
             </a:r>
           </a:p>
         </p:txBody>
@@ -3821,7 +3821,7 @@
               </a:defRPr>
             </a:pPr>
             <a:r>
-              <a:t>Team: SolarSentinels</a:t>
+              <a:t>Team: SuryaDrishti</a:t>
             </a:r>
           </a:p>
           <a:p>
@@ -3854,6 +3854,38 @@
             </a:pPr>
             <a:r>
               <a:t>  Algorithm design, data pipeline integration, and machine learning modeling.</a:t>
+            </a:r>
+          </a:p>
+          <a:p>
+            <a:pPr>
+              <a:spcAft>
+                <a:spcPts val="200"/>
+              </a:spcAft>
+              <a:defRPr sz="1800" b="1">
+                <a:solidFill>
+                  <a:srgbClr val="009664"/>
+                </a:solidFill>
+                <a:latin typeface="Arial"/>
+              </a:defRPr>
+            </a:pPr>
+            <a:r>
+              <a:t>• Rituraj Saha</a:t>
+            </a:r>
+          </a:p>
+          <a:p>
+            <a:pPr>
+              <a:spcAft>
+                <a:spcPts val="1000"/>
+              </a:spcAft>
+              <a:defRPr sz="1500">
+                <a:solidFill>
+                  <a:srgbClr val="282828"/>
+                </a:solidFill>
+                <a:latin typeface="Arial"/>
+              </a:defRPr>
+            </a:pPr>
+            <a:r>
+              <a:t>  Feature engineering, telemetry calibration, and scientific visualization.</a:t>
             </a:r>
           </a:p>
           <a:p>
@@ -4525,7 +4557,7 @@
               </a:defRPr>
             </a:pPr>
             <a:r>
-              <a:t>The SolarSentinels Solution</a:t>
+              <a:t>The SuryaDrishti Solution</a:t>
             </a:r>
           </a:p>
           <a:p>

</xml_diff>